<commit_message>
Expand session workflows with end-to-end ML guides
</commit_message>
<xml_diff>
--- a/getting_started/getting_started.pptx
+++ b/getting_started/getting_started.pptx
@@ -3116,7 +3116,7 @@
             </a:pPr>
             <a:r>
               <a:rPr/>
-              <a:t>Session 1: Getting Started with Orange</a:t>
+              <a:t>Getting Started with Orange</a:t>
             </a:r>
           </a:p>
         </p:txBody>
@@ -3139,28 +3139,28 @@
             <a:pPr lvl="0"/>
             <a:r>
               <a:rPr/>
-              <a:t>Four sessions, one destination: confident data analysis with Orange.</a:t>
+              <a:t>Question: can measurements predict species for unseen flowers?</a:t>
             </a:r>
           </a:p>
           <a:p>
             <a:pPr lvl="0"/>
             <a:r>
               <a:rPr/>
-              <a:t>Today: Orange basics. Next: statistics, cleaning &amp; EDA, then regression.</a:t>
+              <a:t>Today: one complete analysis with the bundled iris data.</a:t>
             </a:r>
           </a:p>
           <a:p>
             <a:pPr lvl="0"/>
             <a:r>
               <a:rPr/>
-              <a:t>Today’s outcomes: read a workflow, check a table, drive a chart, save a recipe.</a:t>
+              <a:t>Next: statistics, cleaning and EDA, then regression.</a:t>
             </a:r>
           </a:p>
           <a:p>
             <a:pPr lvl="0"/>
             <a:r>
               <a:rPr/>
-              <a:t>Watch and discuss — no software or typing needed on your side.</a:t>
+              <a:t>Watch and discuss. No installation or typing required.</a:t>
             </a:r>
           </a:p>
         </p:txBody>
@@ -3207,7 +3207,7 @@
             </a:pPr>
             <a:r>
               <a:rPr/>
-              <a:t>Orange vs Python</a:t>
+              <a:t>Orange and Python</a:t>
             </a:r>
           </a:p>
         </p:txBody>
@@ -3230,28 +3230,28 @@
             <a:pPr lvl="0"/>
             <a:r>
               <a:rPr/>
-              <a:t>Orange is visual data analysis: you connect widgets instead of writing code.</a:t>
+              <a:t>Orange connects ready-made analysis operations visually.</a:t>
             </a:r>
           </a:p>
           <a:p>
             <a:pPr lvl="0"/>
             <a:r>
               <a:rPr/>
-              <a:t>Python is a programming language: you write instructions yourself.</a:t>
+              <a:t>Python expresses operations through code.</a:t>
             </a:r>
           </a:p>
           <a:p>
             <a:pPr lvl="0"/>
             <a:r>
               <a:rPr/>
-              <a:t>In Orange you change a setting and see the result immediately.</a:t>
+              <a:t>A widget performs a step. A connection carries an output.</a:t>
             </a:r>
           </a:p>
           <a:p>
             <a:pPr lvl="0"/>
             <a:r>
               <a:rPr/>
-              <a:t>Under the hood Orange runs Python; today you drive it through the canvas.</a:t>
+              <a:t>Outputs include tables, learners, fitted models, and results.</a:t>
             </a:r>
           </a:p>
         </p:txBody>
@@ -3298,7 +3298,7 @@
             </a:pPr>
             <a:r>
               <a:rPr/>
-              <a:t>The Canvas: Widgets and Connections</a:t>
+              <a:t>Six Stages of an Analysis</a:t>
             </a:r>
           </a:p>
         </p:txBody>
@@ -3318,41 +3318,57 @@
           <a:bodyPr/>
           <a:lstStyle/>
           <a:p>
-            <a:pPr lvl="0"/>
+            <a:pPr lvl="0" indent="-342900" marL="342900">
+              <a:buAutoNum type="arabicPeriod"/>
+            </a:pPr>
             <a:r>
               <a:rPr/>
-              <a:t>Canvas: the workspace holding one analysis; saved as a single </a:t>
-            </a:r>
-            <a:r>
-              <a:rPr>
-                <a:latin typeface="Courier"/>
-              </a:rPr>
-              <a:t>.ows</a:t>
-            </a:r>
+              <a:t>Define the question and useful evidence.</a:t>
+            </a:r>
+          </a:p>
+          <a:p>
+            <a:pPr lvl="0" indent="-342900" marL="342900">
+              <a:buAutoNum type="arabicPeriod"/>
+            </a:pPr>
             <a:r>
               <a:rPr/>
-              <a:t> file.</a:t>
-            </a:r>
-          </a:p>
-          <a:p>
-            <a:pPr lvl="0"/>
+              <a:t>Understand rows, columns, and data quality.</a:t>
+            </a:r>
+          </a:p>
+          <a:p>
+            <a:pPr lvl="0" indent="-342900" marL="342900">
+              <a:buAutoNum type="arabicPeriod"/>
+            </a:pPr>
             <a:r>
               <a:rPr/>
-              <a:t>Widget: one block, one job — read data, show a table, draw a chart.</a:t>
-            </a:r>
-          </a:p>
-          <a:p>
-            <a:pPr lvl="0"/>
+              <a:t>Prepare features within the learning process.</a:t>
+            </a:r>
+          </a:p>
+          <a:p>
+            <a:pPr lvl="0" indent="-342900" marL="342900">
+              <a:buAutoNum type="arabicPeriod"/>
+            </a:pPr>
             <a:r>
               <a:rPr/>
-              <a:t>Connection: from a widget’s output (right) to another’s input (left).</a:t>
-            </a:r>
-          </a:p>
-          <a:p>
-            <a:pPr lvl="0"/>
+              <a:t>Train a baseline and competing models.</a:t>
+            </a:r>
+          </a:p>
+          <a:p>
+            <a:pPr lvl="0" indent="-342900" marL="342900">
+              <a:buAutoNum type="arabicPeriod"/>
+            </a:pPr>
             <a:r>
               <a:rPr/>
-              <a:t>The connection carries data — a table of rows — not decoration.</a:t>
+              <a:t>Evaluate on rows withheld from fitting.</a:t>
+            </a:r>
+          </a:p>
+          <a:p>
+            <a:pPr lvl="0" indent="-342900" marL="342900">
+              <a:buAutoNum type="arabicPeriod"/>
+            </a:pPr>
+            <a:r>
+              <a:rPr/>
+              <a:t>Interpret errors and communicate limits.</a:t>
             </a:r>
           </a:p>
         </p:txBody>
@@ -3399,7 +3415,7 @@
             </a:pPr>
             <a:r>
               <a:rPr/>
-              <a:t>Where Today’s Data Comes From</a:t>
+              <a:t>The Iris Dataset</a:t>
             </a:r>
           </a:p>
         </p:txBody>
@@ -3422,28 +3438,38 @@
             <a:pPr lvl="0"/>
             <a:r>
               <a:rPr/>
-              <a:t>Ships with Orange: the iris dataset — no download, no accounts.</a:t>
+              <a:t>Bundled with Orange. No download during class.</a:t>
             </a:r>
           </a:p>
           <a:p>
             <a:pPr lvl="0"/>
             <a:r>
               <a:rPr/>
-              <a:t>150 rows: one flower measured per row.</a:t>
+              <a:t>150 flowers, with four numeric measurements each.</a:t>
             </a:r>
           </a:p>
           <a:p>
             <a:pPr lvl="0"/>
             <a:r>
               <a:rPr/>
-              <a:t>Four numeric measurements: sepal and petal length and width.</a:t>
+              <a:t>Three recorded species form the categorical target.</a:t>
             </a:r>
           </a:p>
           <a:p>
             <a:pPr lvl="0"/>
             <a:r>
               <a:rPr/>
-              <a:t>One categorical outcome: the species, three values.</a:t>
+              <a:t>Our expanded course workflow is </a:t>
+            </a:r>
+            <a:r>
+              <a:rPr>
+                <a:latin typeface="Courier"/>
+              </a:rPr>
+              <a:t>iris_end_to_end.ows</a:t>
+            </a:r>
+            <a:r>
+              <a:rPr/>
+              <a:t>.</a:t>
             </a:r>
           </a:p>
         </p:txBody>
@@ -3490,7 +3516,7 @@
             </a:pPr>
             <a:r>
               <a:rPr/>
-              <a:t>Every Column Has a Role</a:t>
+              <a:t>Column Roles and Preparation</a:t>
             </a:r>
           </a:p>
         </p:txBody>
@@ -3513,28 +3539,28 @@
             <a:pPr lvl="0"/>
             <a:r>
               <a:rPr/>
-              <a:t>Feature — an input the analysis may use: the four measurements.</a:t>
+              <a:t>Features: sepal and petal measurements.</a:t>
             </a:r>
           </a:p>
           <a:p>
             <a:pPr lvl="0"/>
             <a:r>
               <a:rPr/>
-              <a:t>Target — the column to explain: the species.</a:t>
+              <a:t>Target: species. Meta columns carry labels or identifiers.</a:t>
             </a:r>
           </a:p>
           <a:p>
             <a:pPr lvl="0"/>
             <a:r>
               <a:rPr/>
-              <a:t>Meta — carried along, never an input: none in today’s data.</a:t>
+              <a:t>Imputation and scaling learn from training rows.</a:t>
             </a:r>
           </a:p>
           <a:p>
             <a:pPr lvl="0"/>
             <a:r>
               <a:rPr/>
-              <a:t>The File window shows each column’s type and role; check them first.</a:t>
+              <a:t>Each validation fold fits its own preparation steps.</a:t>
             </a:r>
           </a:p>
         </p:txBody>
@@ -3581,7 +3607,7 @@
             </a:pPr>
             <a:r>
               <a:rPr/>
-              <a:t>Today’s Workflow: Two Shipped Examples</a:t>
+              <a:t>Training and Evaluation</a:t>
             </a:r>
           </a:p>
         </p:txBody>
@@ -3604,28 +3630,28 @@
             <a:pPr lvl="0"/>
             <a:r>
               <a:rPr/>
-              <a:t>“File and Data Table”: one block reads, one shows the rows.</a:t>
+              <a:t>Reserve 20% of rows as a holdout before exploration.</a:t>
             </a:r>
           </a:p>
           <a:p>
             <a:pPr lvl="0"/>
             <a:r>
               <a:rPr/>
-              <a:t>“Interactive Visualizations”: File → Scatter Plot → Data Table.</a:t>
+              <a:t>Explore the 80% training portion and use five-fold CV.</a:t>
             </a:r>
           </a:p>
           <a:p>
             <a:pPr lvl="0"/>
             <a:r>
               <a:rPr/>
-              <a:t>The second table is fed by the chart’s Selected Data, not by the file.</a:t>
+              <a:t>Compare Constant, Logistic Regression, and Tree.</a:t>
             </a:r>
           </a:p>
           <a:p>
             <a:pPr lvl="0"/>
             <a:r>
               <a:rPr/>
-              <a:t>Select points in the chart; the table follows live.</a:t>
+              <a:t>Report the separate holdout check after model comparison.</a:t>
             </a:r>
           </a:p>
         </p:txBody>
@@ -3672,7 +3698,7 @@
             </a:pPr>
             <a:r>
               <a:rPr/>
-              <a:t>Recap and What Comes Next</a:t>
+              <a:t>Interpretation and Next Steps</a:t>
             </a:r>
           </a:p>
         </p:txBody>
@@ -3695,28 +3721,28 @@
             <a:pPr lvl="0"/>
             <a:r>
               <a:rPr/>
-              <a:t>We read a workflow, checked 150 rows, 4 features, 1 outcome.</a:t>
+              <a:t>Inspect confusion patterns and individual predictions.</a:t>
             </a:r>
           </a:p>
           <a:p>
             <a:pPr lvl="0"/>
             <a:r>
               <a:rPr/>
-              <a:t>We changed axes, selected points, and watched a table follow.</a:t>
+              <a:t>Record the source, split, settings, scores, and limits.</a:t>
             </a:r>
           </a:p>
           <a:p>
             <a:pPr lvl="0"/>
             <a:r>
               <a:rPr/>
-              <a:t>We saved the recipe — the workflow stores structure, not rows.</a:t>
+              <a:t>Save the workflow and use its implementation guide.</a:t>
             </a:r>
           </a:p>
           <a:p>
             <a:pPr lvl="0"/>
             <a:r>
               <a:rPr/>
-              <a:t>Next session: descriptive and inferential statistics on the same data.</a:t>
+              <a:t>Next session: statistics with the bundled heart data.</a:t>
             </a:r>
           </a:p>
         </p:txBody>

</xml_diff>